<commit_message>
Fixed UML and presentation
</commit_message>
<xml_diff>
--- a/presentation/LSMSDB_Project IDEA Presentation.pptx
+++ b/presentation/LSMSDB_Project IDEA Presentation.pptx
@@ -276,7 +276,7 @@
           <a:p>
             <a:fld id="{0EF95162-6873-F647-B392-BF6A1F606277}" type="datetimeFigureOut">
               <a:rPr lang="it-IT" smtClean="0"/>
-              <a:t>18/10/2026</a:t>
+              <a:t>19/10/2026</a:t>
             </a:fld>
             <a:endParaRPr lang="it-IT"/>
           </a:p>
@@ -730,7 +730,7 @@
           <a:p>
             <a:fld id="{2FDCBEE4-315A-8E42-835E-29A1DAE07625}" type="datetimeFigureOut">
               <a:rPr lang="it-IT" smtClean="0"/>
-              <a:t>18/10/2026</a:t>
+              <a:t>19/10/2026</a:t>
             </a:fld>
             <a:endParaRPr lang="it-IT"/>
           </a:p>
@@ -922,7 +922,7 @@
           <a:p>
             <a:fld id="{2FDCBEE4-315A-8E42-835E-29A1DAE07625}" type="datetimeFigureOut">
               <a:rPr lang="it-IT" smtClean="0"/>
-              <a:t>18/10/2026</a:t>
+              <a:t>19/10/2026</a:t>
             </a:fld>
             <a:endParaRPr lang="it-IT"/>
           </a:p>
@@ -1124,7 +1124,7 @@
           <a:p>
             <a:fld id="{2FDCBEE4-315A-8E42-835E-29A1DAE07625}" type="datetimeFigureOut">
               <a:rPr lang="it-IT" smtClean="0"/>
-              <a:t>18/10/2026</a:t>
+              <a:t>19/10/2026</a:t>
             </a:fld>
             <a:endParaRPr lang="it-IT"/>
           </a:p>
@@ -1316,7 +1316,7 @@
           <a:p>
             <a:fld id="{2FDCBEE4-315A-8E42-835E-29A1DAE07625}" type="datetimeFigureOut">
               <a:rPr lang="it-IT" smtClean="0"/>
-              <a:t>18/10/2026</a:t>
+              <a:t>19/10/2026</a:t>
             </a:fld>
             <a:endParaRPr lang="it-IT"/>
           </a:p>
@@ -1585,7 +1585,7 @@
           <a:p>
             <a:fld id="{2FDCBEE4-315A-8E42-835E-29A1DAE07625}" type="datetimeFigureOut">
               <a:rPr lang="it-IT" smtClean="0"/>
-              <a:t>18/10/2026</a:t>
+              <a:t>19/10/2026</a:t>
             </a:fld>
             <a:endParaRPr lang="it-IT"/>
           </a:p>
@@ -1894,7 +1894,7 @@
           <a:p>
             <a:fld id="{2FDCBEE4-315A-8E42-835E-29A1DAE07625}" type="datetimeFigureOut">
               <a:rPr lang="it-IT" smtClean="0"/>
-              <a:t>18/10/2026</a:t>
+              <a:t>19/10/2026</a:t>
             </a:fld>
             <a:endParaRPr lang="it-IT"/>
           </a:p>
@@ -2337,7 +2337,7 @@
           <a:p>
             <a:fld id="{2FDCBEE4-315A-8E42-835E-29A1DAE07625}" type="datetimeFigureOut">
               <a:rPr lang="it-IT" smtClean="0"/>
-              <a:t>18/10/2026</a:t>
+              <a:t>19/10/2026</a:t>
             </a:fld>
             <a:endParaRPr lang="it-IT"/>
           </a:p>
@@ -2478,7 +2478,7 @@
           <a:p>
             <a:fld id="{2FDCBEE4-315A-8E42-835E-29A1DAE07625}" type="datetimeFigureOut">
               <a:rPr lang="it-IT" smtClean="0"/>
-              <a:t>18/10/2026</a:t>
+              <a:t>19/10/2026</a:t>
             </a:fld>
             <a:endParaRPr lang="it-IT"/>
           </a:p>
@@ -2597,7 +2597,7 @@
           <a:p>
             <a:fld id="{2FDCBEE4-315A-8E42-835E-29A1DAE07625}" type="datetimeFigureOut">
               <a:rPr lang="it-IT" smtClean="0"/>
-              <a:t>18/10/2026</a:t>
+              <a:t>19/10/2026</a:t>
             </a:fld>
             <a:endParaRPr lang="it-IT"/>
           </a:p>
@@ -2896,7 +2896,7 @@
           <a:p>
             <a:fld id="{2FDCBEE4-315A-8E42-835E-29A1DAE07625}" type="datetimeFigureOut">
               <a:rPr lang="it-IT" smtClean="0"/>
-              <a:t>18/10/2026</a:t>
+              <a:t>19/10/2026</a:t>
             </a:fld>
             <a:endParaRPr lang="it-IT"/>
           </a:p>
@@ -3172,7 +3172,7 @@
           <a:p>
             <a:fld id="{2FDCBEE4-315A-8E42-835E-29A1DAE07625}" type="datetimeFigureOut">
               <a:rPr lang="it-IT" smtClean="0"/>
-              <a:t>18/10/2026</a:t>
+              <a:t>19/10/2026</a:t>
             </a:fld>
             <a:endParaRPr lang="it-IT"/>
           </a:p>
@@ -3999,7 +3999,7 @@
         <p:spPr>
           <a:xfrm>
             <a:off x="538843" y="1469572"/>
-            <a:ext cx="7494814" cy="3416320"/>
+            <a:ext cx="7494814" cy="3139321"/>
           </a:xfrm>
           <a:prstGeom prst="rect">
             <a:avLst/>
@@ -4024,7 +4024,7 @@
             </a:pPr>
             <a:r>
               <a:rPr lang="en-US" dirty="0"/>
-              <a:t>The system must recommend games similar to those played by the user</a:t>
+              <a:t>The system must allow the creation of friendships between users</a:t>
             </a:r>
           </a:p>
           <a:p>
@@ -4034,7 +4034,7 @@
             </a:pPr>
             <a:r>
               <a:rPr lang="en-US" dirty="0"/>
-              <a:t>The system must allow the creation of friendships between users</a:t>
+              <a:t>The system must display the friends who have played a specified game</a:t>
             </a:r>
           </a:p>
           <a:p>
@@ -4044,17 +4044,7 @@
             </a:pPr>
             <a:r>
               <a:rPr lang="en-US" dirty="0"/>
-              <a:t>The system must allow a user to view another user's profile</a:t>
-            </a:r>
-          </a:p>
-          <a:p>
-            <a:pPr marL="285750" indent="-285750">
-              <a:buFont typeface="Arial" panose="020B0604020202020204" pitchFamily="34" charset="0"/>
-              <a:buChar char="•"/>
-            </a:pPr>
-            <a:r>
-              <a:rPr lang="en-US" dirty="0"/>
-              <a:t>The system must display the friends who have played a specified game</a:t>
+              <a:t>The system must recommend games similar to those played by the user</a:t>
             </a:r>
           </a:p>
           <a:p>
@@ -4882,7 +4872,7 @@
           <a:p>
             <a:r>
               <a:rPr lang="en-US" dirty="0"/>
-              <a:t>Actors and main mock-ups (iii)</a:t>
+              <a:t>Actors and main mock-ups (iv)</a:t>
             </a:r>
           </a:p>
         </p:txBody>
@@ -5339,10 +5329,10 @@
       </p:sp>
       <p:pic>
         <p:nvPicPr>
-          <p:cNvPr id="7" name="Graphic 6">
+          <p:cNvPr id="4" name="Graphic 3">
             <a:extLst>
               <a:ext uri="{FF2B5EF4-FFF2-40B4-BE49-F238E27FC236}">
-                <a16:creationId xmlns:a16="http://schemas.microsoft.com/office/drawing/2014/main" id="{778991F4-EEBB-7612-AE86-3B7984FDB17C}"/>
+                <a16:creationId xmlns:a16="http://schemas.microsoft.com/office/drawing/2014/main" id="{B1408578-2493-5C0A-D799-63B704A2484E}"/>
               </a:ext>
             </a:extLst>
           </p:cNvPr>
@@ -5365,8 +5355,8 @@
         </p:blipFill>
         <p:spPr>
           <a:xfrm>
-            <a:off x="419269" y="1299081"/>
-            <a:ext cx="8288739" cy="4483112"/>
+            <a:off x="696084" y="1474626"/>
+            <a:ext cx="8248454" cy="4461323"/>
           </a:xfrm>
           <a:prstGeom prst="rect">
             <a:avLst/>

</xml_diff>